<commit_message>
Néerlandais 1: Uitspraak! — Dutch review fixes
Raclé ch noted « gh » consistently, oranje « o-ra-gneu », monosyllable rule
limited to words read alone, prefix-only unstressed be-/ge-/ver-, -en in
Belgium, reuzenuien, Koen instead of moe, man/maan on the cover, revised
loto traps and Scheveningen note.

Co-Authored-By: Claude Opus 5.5 <noreply@anthropic.com>
Claude-Session: https://claude.ai/code/session_01GHo9GbchfMk8JhTz1kwo92
</commit_message>
<xml_diff>
--- a/neerlandais1/powerpoints/Uitspraak_5_seances.pptx
+++ b/neerlandais1/powerpoints/Uitspraak_5_seances.pptx
@@ -128,52 +128,52 @@
   <p:extLst>
     <p:ext uri="{521415D9-36F7-43E2-AB2F-B90AF26B5E84}">
       <p14:sectionLst xmlns:p14="http://schemas.microsoft.com/office/powerpoint/2010/main">
-        <p14:section name="Ouverture" id="{fab37906-8d94-bb34-aaa8-3c3aed74b550}">
+        <p14:section name="Ouverture" id="{0d0102e8-163b-cde8-e684-84f0de8bdb12}">
           <p14:sldIdLst>
             <p14:sldId id="256"/>
           </p14:sldIdLst>
         </p14:section>
-        <p14:section name="Le parcours" id="{9ed09cfb-ec2a-690b-2dcc-46bc209b8283}">
+        <p14:section name="Le parcours" id="{d98c319c-051e-b704-cf98-c69d054f38b5}">
           <p14:sldIdLst>
             <p14:sldId id="257"/>
           </p14:sldIdLst>
         </p14:section>
-        <p14:section name="Séance 1 · Long ou court ?" id="{5ea98c50-5f68-0624-ebb0-13e279dfce68}">
+        <p14:section name="Séance 1 · Long ou court ?" id="{d7c2525e-04f4-66ab-e4a9-ec22fc73b641}">
           <p14:sldIdLst>
             <p14:sldId id="258"/>
             <p14:sldId id="259"/>
             <p14:sldId id="260"/>
           </p14:sldIdLst>
         </p14:section>
-        <p14:section name="Séance 2 · Les sons doubles" id="{1b11cae7-1c19-db77-a173-47e790505b32}">
+        <p14:section name="Séance 2 · Les sons doubles" id="{6852860a-850e-7ce1-e8c4-8dc70556af70}">
           <p14:sldIdLst>
             <p14:sldId id="261"/>
             <p14:sldId id="262"/>
             <p14:sldId id="263"/>
           </p14:sldIdLst>
         </p14:section>
-        <p14:section name="Séance 3 · Les consonnes-pièges" id="{1e1ff4fd-e6ee-bcbf-eb9b-72fc88df621f}">
+        <p14:section name="Séance 3 · Les consonnes-pièges" id="{07f9cdf2-72c7-70c3-db4b-d8ff3fd89a2e}">
           <p14:sldIdLst>
             <p14:sldId id="264"/>
             <p14:sldId id="265"/>
             <p14:sldId id="266"/>
           </p14:sldIdLst>
         </p14:section>
-        <p14:section name="Séance 4 · Mots courts, mots longs" id="{dfdc48b2-bfdf-cf62-2235-4508148f6bd6}">
+        <p14:section name="Séance 4 · Mots courts, mots longs" id="{4ab83ceb-a381-d50e-3cc3-82838c4231ca}">
           <p14:sldIdLst>
             <p14:sldId id="267"/>
             <p14:sldId id="268"/>
             <p14:sldId id="269"/>
           </p14:sldIdLst>
         </p14:section>
-        <p14:section name="Séance 5 · La phrase qui chante" id="{a3dc907a-7487-2692-6833-57d3f46116b6}">
+        <p14:section name="Séance 5 · La phrase qui chante" id="{d4ae93e7-c902-ca86-8aa1-eaf1c549bbfe}">
           <p14:sldIdLst>
             <p14:sldId id="270"/>
             <p14:sldId id="271"/>
             <p14:sldId id="272"/>
           </p14:sldIdLst>
         </p14:section>
-        <p14:section name="Annexe · Corrigés" id="{f2012356-4089-f48b-2900-a643a46cf2b5}">
+        <p14:section name="Annexe · Corrigés" id="{a4604c1b-0b33-417b-4cef-1297af81d925}">
           <p14:sldIdLst>
             <p14:sldId id="273"/>
             <p14:sldId id="274"/>
@@ -587,7 +587,7 @@
             <a:r>
               <a:rPr lang="en-US" dirty="0"/>
               <a:t>Objectif : Annoncer le parcours : 5 séances pour bien prononcer le néerlandais.
-Lisez les cinq mots de la ligne d'accroche et demandez : « Qu'est-ce qui change d'un mot à l'autre ? » Réponse : voyelle courte (kat) et longue (kaat), son double (kijk), g raclé (goed), mot long (gezellig). Ce sont les quatre premières séances ; la cinquième les réunit dans la phrase.</a:t>
+Lisez les cinq mots de la ligne d'accroche et demandez : « Qu'est-ce qui change d'un mot à l'autre ? » Réponse : voyelle courte (man) et longue (maan), son double (kijk), g raclé (goed), mot long (gezellig). Ce sont les quatre premières séances ; la cinquième les réunit dans la phrase.</a:t>
             </a:r>
             <a:endParaRPr lang="en-US" dirty="0"/>
           </a:p>
@@ -765,7 +765,7 @@
             <a:r>
               <a:rPr lang="en-US" dirty="0"/>
               <a:t>Objectif : Réinvestir toutes les consonnes-pièges dans un jeu de plateau.
-Aide-mémoire : goed (« ghout », d → t) · hallo (h soufflé) · jij (« yèï ») · dag (g final raclé) · brengen (ng) · meisje (« mèï-cheu ») · hebben (h, e muet) · school (s + ch) · oranje (« o-ran-gneu ») · denken (nk) · Russisch (« reu-sis ») · alsjeblieft (sj) · Tsjechië (« tchè-chi-yeu »). Jouez en 2 à 4 équipes, avec un pion par équipe.</a:t>
+Aide-mémoire : goed (« ghout » : gh raclé, d → t) · hallo (h soufflé) · jij (« yèï ») · dag (g final raclé) · brengen (ng) · meisje (« mèï-cheu ») · hebben (h, e muet) · school (s + ch) · oranje (« o-ra-gneu », comme montagne, accent sur ra) · denken (nk) · Russisch (« reu-sis ») · alsjeblieft (sj) · Tsjechië (« tchè-ghi-yeu », gh raclé). Jouez en 2 à 4 équipes, avec un pion par équipe.</a:t>
             </a:r>
             <a:endParaRPr lang="en-US" dirty="0"/>
           </a:p>
@@ -854,7 +854,7 @@
             <a:r>
               <a:rPr lang="en-US" dirty="0"/>
               <a:t>Objectif : Donner une méthode pour lire efficacement un mot d'une ou de plusieurs syllabes.
-C'est la seule diapo de théorie du parcours : elle reprend la méthode en 3 étapes du M1 (diapo 13) et ajoute l'accent tonique. Corrigé du mini-défi : be·ta·len (be muet, ta long, len muet) · ge·zel·lig (ge muet, zel court, lig « leuch ») · vrien·de·lijk (vrien « vrinn », de muet, lijk « leuk »). Faites frapper les syllabes dans les mains et taper du pied sur la syllabe accentuée. L'accent néerlandais est fort : la syllabe accentuée est plus longue et plus haute, les autres s'effacent.</a:t>
+C'est la seule diapo de théorie du parcours : elle reprend la méthode en 3 étapes du M1 (diapo 13) et ajoute l'accent tonique. Corrigé du mini-défi : be·ta·len (be muet, ta long, len muet) · ge·zel·lig (ge muet, zel court, lig « leugh ») · vrien·de·lijk (vrien « vrinn », de muet, lijk « leuk »). Faites frapper les syllabes dans les mains et taper du pied sur la syllabe accentuée. L'accent néerlandais est fort : la syllabe accentuée est plus longue et plus haute, les autres s'effacent.</a:t>
             </a:r>
             <a:endParaRPr lang="en-US" dirty="0"/>
           </a:p>
@@ -948,7 +948,7 @@
 • NAAM (1) · NA·men (2) · VOOR·naam (2) · ACH·ter·naam (3) · ACH·ter·na·men (4)
 • WERK (1) · WER·ken (2) · ge·WERKT (2) · ME·de·wer·ker (4) · ME·de·wer·kers (4)
 • HUIS (1) · HUI·zen (2) · HUIS·je (2) · ZIE·ken·huis (3) · ZIE·ken·hui·zen (4)
-Observation : l'accent ne bouge pas quand on ajoute une finale (ta·len → ver·ta·len). Dans un mot composé, il passe sur le premier mot (zie·ken·huis). taal → talen : la porte s'ouvre, une seule voyelle suffit (M1).</a:t>
+Observation : l'accent ne bouge pas quand on ajoute un préfixe ou une finale (ta·len → ver·ta·len → ver·ta·lin·gen). Dans un mot composé, il passe sur le premier mot (zie·ken·huis). taal → talen : la porte s'ouvre, une seule voyelle suffit (M1).</a:t>
             </a:r>
             <a:endParaRPr lang="en-US" dirty="0"/>
           </a:p>
@@ -1037,7 +1037,7 @@
             <a:r>
               <a:rPr lang="en-US" dirty="0"/>
               <a:t>Objectif : Lire sans hésiter des mots longs du quotidien et du travail.
-Corrigé : moei·lijk (2) · mak·ke·lijk (3) · ge·zond·heid (3) · na·tuur·lijk (3) · for·mu·lier (3) · woor·den·schat (3) · in·lich·tin·gen (4) · na·tio·na·li·teit (5) · ar·beids·on·ge·schikt·heids·ver·ze·ke·ring (10). Pièges : -lijk = « leuk », -heid garde son ei, -tio- se prononce « tsio » ou « sio ». Sens : difficile · facile · santé · naturellement · formulaire · vocabulaire · renseignements · nationalité · assurance invalidité (le mot-boss est célèbre pour sa longueur).</a:t>
+Corrigé : moei·lijk (2) · mak·ke·lijk (3) · ge·zond·heid (3) · na·tuur·lijk (3) · for·mu·lier (3) · woor·den·schat (3) · in·lich·tin·gen (4) · na·tio·na·li·teit (5) · ar·beids·on·ge·schikt·heids·ver·ze·ke·ring (10). Pièges : -lijk = « leuk », -heid garde son ei, -tio- se prononce « tsio » ou « sio ». Sens : difficile · facile · santé · naturellement · formulaire · vocabulaire · renseignements · nationalité · assurance invalidité (le mot-boss est célèbre pour sa longueur). En Belgique, on dit souvent ge·mak·ke·lijk (4 syllabes) : acceptez-le.</a:t>
             </a:r>
             <a:endParaRPr lang="en-US" dirty="0"/>
           </a:p>
@@ -1215,7 +1215,7 @@
             <a:r>
               <a:rPr lang="en-US" dirty="0"/>
               <a:t>Objectif : Enchaîner tous les sons du parcours avec rythme, grâce aux virelangues.
-Sens : 1 Le chat gratte les boucles de l'escalier. 2 Liesje apprenait à Lotje à marcher le long de la longue allée des Tilleuls. 3 Je m'appelle Hans et j'aime manger du hareng. 4 Huit oies grises sont allées hier, toutes contentes, à Gand. 5 Le cocher astique la diligence avec du produit pour diligence. 6 Quand des mouches volent derrière des mouches, des mouches poursuivent des mouches (vliegen = les mouches et voler). Les virelangues 1, 2, 5 et 6 sont des classiques ; 3 et 4 ont été créés pour ce parcours. Lisez d'abord lentement, syllabe par syllabe.</a:t>
+Sens : 1 Le chat gratte les boucles de l'escalier. 2 Liesje apprenait à Lotje à marcher le long de la longue allée des Tilleuls. 3 Je m'appelle Hans et j'aime manger du hareng. 4 Huit oies grises sont allées hier, toutes contentes, à Gand. 5 Le cocher astique la diligence avec du produit à diligence. 6 Quand des mouches volent derrière des mouches, des mouches poursuivent des mouches (vliegen = les mouches et voler). Les virelangues 1, 2, 5 et 6 sont des classiques ; 3 et 4 ont été créés pour ce parcours. Lisez d'abord lentement, syllabe par syllabe.</a:t>
             </a:r>
             <a:endParaRPr lang="en-US" dirty="0"/>
           </a:p>
@@ -1304,7 +1304,7 @@
             <a:r>
               <a:rPr lang="en-US" dirty="0"/>
               <a:t>Objectif : Réviser tout le parcours dans un jeu final en équipes.
-Corrigé : ① court – long – court – long · ② « eu » bref – « u » – « œil » · ③ dictez par exemple klein (ei) et wijn (ij) · ④ h soufflé · ⑤ sche·ve·nin·gen : s + ch raclé, e long, deux e muets · ⑥ « mèï-cheu » · « o-ran-gneu » · « tchè-chi-yeu » · ⑦ ver·ga·de·ring (4) · ⑧ ver·jaar·dags·feest (4) · ⑨ Hoe gaat 't? Scheveningen (station balnéaire près de La Haye) est un mot célèbre : il trahit les non-néerlandophones depuis des siècles. Félicitez chaque tentative !</a:t>
+Corrigé : ① court – long – court – long · ② « eu » bref – « u » – « œil » · ③ dictez par exemple klein (ei) et wijn (ij) · ④ h soufflé · ⑤ sche·ve·nin·gen : s + ch raclé, e long, deux e muets · ⑥ « mèï-cheu » · « o-ra-gneu » · « tchè-ghi-yeu » · ⑦ ver·ga·de·ring (4) · ⑧ ver·jaar·dags·feest (4) · ⑨ Hoe gaat 't? Scheveningen (station balnéaire près de La Haye) est un célèbre mot-test de la Seconde Guerre mondiale : il aurait servi à démasquer les espions allemands. Félicitez chaque tentative !</a:t>
             </a:r>
             <a:endParaRPr lang="en-US" dirty="0"/>
           </a:p>
@@ -1927,7 +1927,7 @@
             <a:r>
               <a:rPr lang="en-US" dirty="0"/>
               <a:t>Objectif : Distinguer à l'oreille les voyelles courtes et longues (a / aa, e / ee, i / ie, o / oo, u / uu).
-Liste à lire (exemple) : maan, vak, laat, pen, been, hel, vies, lid, ziet, bos, boom, pot, muur, kus, zuur. Changez l'ordre à chaque tour. Pour le u : mus ≈ « meus » bref, muur ≈ « mur » long (M1, diapo 12). i / ie : le i long s'écrit toujours ie. Sens utiles : vaak (souvent), laat (tard), peen (carotte), been (jambe), heel (très), vies (sale), lied (chanson), boos (fâché), poot (patte), muur (mur), zuur (acide).</a:t>
+Liste à lire (exemple) : maan, vak, laat, pen, been, hel, vies, lid, ziet, bos, boom, pot, muur, kus, zuur. Changez l'ordre à chaque tour. Pour le u : mus ≈ « meus » bref, muur ≈ « mur » long (M1, diapo 12). i / ie : le son « i » s'écrit presque toujours ie (sauf emprunts : juni, kilo). En réalité, la différence est surtout de timbre : i bref est plus ouvert, presque « é » ; ie = « i » français, allongé seulement devant r (bier). Sens utiles : vaak (souvent), laat (tard), peen (carotte), been (jambe), heel (très), vies (sale), lied (chanson), boos (fâché), poot (patte), muur (mur), zuur (acide).</a:t>
             </a:r>
             <a:endParaRPr lang="en-US" dirty="0"/>
           </a:p>
@@ -2372,7 +2372,7 @@
             <a:r>
               <a:rPr lang="en-US" dirty="0"/>
               <a:t>Objectif : Repérer et enchaîner les sons doubles dans une phrase, y compris les sons à trois lettres.
-Corrigé : 1 → 2 (oei, ui) · 2 → 4 (oe, ij, eu, ui) · 3 → 3 (ei, oe, ui) · 4 → 6 (IJ, ou, ie, ui, eu, oe) · 5 → 6 (ooi, ieuw, ui, ij, ooi, aai). Dans leren, e est long mais simple : ce n'est pas un son double. Sens : 1 Salut ! Je rentre à la maison. 2 Les mères coupent des oignons géants. 3 Apprendre à tricoter des pulls verts. 4 Une bière glacée de la cuisine de maman. 5 Les beaux pulls neufs ne sont jamais ennuyeux.</a:t>
+Corrigé : 1 → 2 (oei, ui) · 2 → 4 (oe, ij, eu, ui) · 3 → 3 (ei, oe, ui) · 4 → 6 (IJ, ou, ie, ui, eu, oe) · 5 → 6 (ooi, ieuw, ui, ij, ooi, aai). Dans leren, e est long mais simple : ce n'est pas un son double. Sens : 1 Salut ! Je rentre à la maison. 2 Les mères coupent des oignons géants. 3 Apprendre à tricoter des pulls verts. 4 Une bière glacée de la cuisine de Koen. Doei! s'entend surtout aux Pays-Bas ; en Flandre, on dit plutôt Daag! 5 Les beaux pulls neufs ne sont jamais ennuyeux.</a:t>
             </a:r>
             <a:endParaRPr lang="en-US" dirty="0"/>
           </a:p>
@@ -3452,7 +3452,7 @@
                   <a:srgbClr val="FFFFFF"/>
                 </a:solidFill>
               </a:rPr>
-              <a:t>kat · kaat · kijk · goed · gezellig</a:t>
+              <a:t>man · maan · kijk · goed · gezellig</a:t>
             </a:r>
             <a:endParaRPr lang="en-US" sz="2000" dirty="0"/>
           </a:p>
@@ -12124,6 +12124,39 @@
             </a:r>
             <a:endParaRPr lang="en-US" sz="1500" dirty="0"/>
           </a:p>
+          <a:p>
+            <a:pPr algn="l" indent="0" marL="0">
+              <a:spcAft>
+                <a:spcPts val="700"/>
+              </a:spcAft>
+              <a:buNone/>
+            </a:pPr>
+            <a:r>
+              <a:rPr lang="en-US" sz="1500" i="1" dirty="0">
+                <a:solidFill>
+                  <a:schemeClr val="tx1"/>
+                </a:solidFill>
+              </a:rPr>
+              <a:t>ch</a:t>
+            </a:r>
+            <a:r>
+              <a:rPr lang="en-US" sz="1500" dirty="0">
+                <a:solidFill>
+                  <a:schemeClr val="tx1"/>
+                </a:solidFill>
+              </a:rPr>
+              <a:t> ferme la porte : </a:t>
+            </a:r>
+            <a:r>
+              <a:rPr lang="en-US" sz="1500" i="1" dirty="0">
+                <a:solidFill>
+                  <a:schemeClr val="tx1"/>
+                </a:solidFill>
+              </a:rPr>
+              <a:t>la·chen</a:t>
+            </a:r>
+            <a:endParaRPr lang="en-US" sz="1500" dirty="0"/>
+          </a:p>
         </p:txBody>
       </p:sp>
       <p:sp>
@@ -12378,7 +12411,7 @@
                   <a:schemeClr val="tx1"/>
                 </a:solidFill>
               </a:rPr>
-              <a:t>jamais </a:t>
+              <a:t>jamais sur les préfixes </a:t>
             </a:r>
             <a:r>
               <a:rPr lang="en-US" sz="1200" i="1" dirty="0">
@@ -12386,7 +12419,7 @@
                   <a:schemeClr val="tx1"/>
                 </a:solidFill>
               </a:rPr>
-              <a:t>be-, ge-, ver-, ont-</a:t>
+              <a:t>be-, ge-, ver-</a:t>
             </a:r>
             <a:r>
               <a:rPr lang="en-US" sz="1200" dirty="0">
@@ -12468,7 +12501,7 @@
                   <a:schemeClr val="tx1"/>
                 </a:solidFill>
               </a:rPr>
-              <a:t>mot français → à la fin : </a:t>
+              <a:t>mot français → souvent à la fin : </a:t>
             </a:r>
             <a:r>
               <a:rPr lang="en-US" sz="1200" i="1" dirty="0">
@@ -12704,15 +12737,39 @@
               <a:buNone/>
             </a:pPr>
             <a:r>
-              <a:rPr lang="en-US" sz="1400" i="1" dirty="0">
-                <a:solidFill>
-                  <a:schemeClr val="tx1"/>
-                </a:solidFill>
-              </a:rPr>
-              <a:t>be-, ge-, ver-, -e, -en, -el, -er</a:t>
-            </a:r>
-            <a:r>
-              <a:rPr lang="en-US" sz="1400" dirty="0">
+              <a:rPr lang="en-US" sz="1200" dirty="0">
+                <a:solidFill>
+                  <a:schemeClr val="tx1"/>
+                </a:solidFill>
+              </a:rPr>
+              <a:t>préfixes </a:t>
+            </a:r>
+            <a:r>
+              <a:rPr lang="en-US" sz="1200" i="1" dirty="0">
+                <a:solidFill>
+                  <a:schemeClr val="tx1"/>
+                </a:solidFill>
+              </a:rPr>
+              <a:t>be-, ge-, ver-</a:t>
+            </a:r>
+            <a:r>
+              <a:rPr lang="en-US" sz="1200" dirty="0">
+                <a:solidFill>
+                  <a:schemeClr val="tx1"/>
+                </a:solidFill>
+              </a:rPr>
+              <a:t>, finales </a:t>
+            </a:r>
+            <a:r>
+              <a:rPr lang="en-US" sz="1200" i="1" dirty="0">
+                <a:solidFill>
+                  <a:schemeClr val="tx1"/>
+                </a:solidFill>
+              </a:rPr>
+              <a:t>-e, -en, -el, -er</a:t>
+            </a:r>
+            <a:r>
+              <a:rPr lang="en-US" sz="1200" dirty="0">
                 <a:solidFill>
                   <a:schemeClr val="tx1"/>
                 </a:solidFill>
@@ -12720,14 +12777,14 @@
               <a:t> = « e » de </a:t>
             </a:r>
             <a:r>
-              <a:rPr lang="en-US" sz="1400" i="1" dirty="0">
+              <a:rPr lang="en-US" sz="1200" i="1" dirty="0">
                 <a:solidFill>
                   <a:schemeClr val="tx1"/>
                 </a:solidFill>
               </a:rPr>
               <a:t>le</a:t>
             </a:r>
-            <a:endParaRPr lang="en-US" sz="1400" dirty="0"/>
+            <a:endParaRPr lang="en-US" sz="1200" dirty="0"/>
           </a:p>
           <a:p>
             <a:pPr algn="l" indent="0" marL="0">
@@ -12737,7 +12794,7 @@
               <a:buNone/>
             </a:pPr>
             <a:r>
-              <a:rPr lang="en-US" sz="1400" i="1" dirty="0">
+              <a:rPr lang="en-US" sz="1200" i="1" dirty="0">
                 <a:solidFill>
                   <a:schemeClr val="tx1"/>
                 </a:solidFill>
@@ -12745,15 +12802,15 @@
               <a:t>-en</a:t>
             </a:r>
             <a:r>
-              <a:rPr lang="en-US" sz="1400" dirty="0">
-                <a:solidFill>
-                  <a:schemeClr val="tx1"/>
-                </a:solidFill>
-              </a:rPr>
-              <a:t> : le </a:t>
-            </a:r>
-            <a:r>
-              <a:rPr lang="en-US" sz="1400" i="1" dirty="0">
+              <a:rPr lang="en-US" sz="1200" dirty="0">
+                <a:solidFill>
+                  <a:schemeClr val="tx1"/>
+                </a:solidFill>
+              </a:rPr>
+              <a:t> : </a:t>
+            </a:r>
+            <a:r>
+              <a:rPr lang="en-US" sz="1200" i="1" dirty="0">
                 <a:solidFill>
                   <a:schemeClr val="tx1"/>
                 </a:solidFill>
@@ -12761,14 +12818,14 @@
               <a:t>n</a:t>
             </a:r>
             <a:r>
-              <a:rPr lang="en-US" sz="1400" dirty="0">
-                <a:solidFill>
-                  <a:schemeClr val="tx1"/>
-                </a:solidFill>
-              </a:rPr>
-              <a:t> s’entend à peine</a:t>
-            </a:r>
-            <a:endParaRPr lang="en-US" sz="1400" dirty="0"/>
+              <a:rPr lang="en-US" sz="1200" dirty="0">
+                <a:solidFill>
+                  <a:schemeClr val="tx1"/>
+                </a:solidFill>
+              </a:rPr>
+              <a:t> avalé (NL) ou prononcé (BE)</a:t>
+            </a:r>
+            <a:endParaRPr lang="en-US" sz="1200" dirty="0"/>
           </a:p>
           <a:p>
             <a:pPr algn="l" indent="0" marL="0">
@@ -12778,7 +12835,7 @@
               <a:buNone/>
             </a:pPr>
             <a:r>
-              <a:rPr lang="en-US" sz="1400" i="1" dirty="0">
+              <a:rPr lang="en-US" sz="1200" i="1" dirty="0">
                 <a:solidFill>
                   <a:schemeClr val="tx1"/>
                 </a:solidFill>
@@ -12786,22 +12843,22 @@
               <a:t>-ig</a:t>
             </a:r>
             <a:r>
-              <a:rPr lang="en-US" sz="1400" dirty="0">
-                <a:solidFill>
-                  <a:schemeClr val="tx1"/>
-                </a:solidFill>
-              </a:rPr>
-              <a:t> « euch » : </a:t>
-            </a:r>
-            <a:r>
-              <a:rPr lang="en-US" sz="1400" i="1" dirty="0">
+              <a:rPr lang="en-US" sz="1200" dirty="0">
+                <a:solidFill>
+                  <a:schemeClr val="tx1"/>
+                </a:solidFill>
+              </a:rPr>
+              <a:t> « eugh » : </a:t>
+            </a:r>
+            <a:r>
+              <a:rPr lang="en-US" sz="1200" i="1" dirty="0">
                 <a:solidFill>
                   <a:schemeClr val="tx1"/>
                 </a:solidFill>
               </a:rPr>
               <a:t>twin·tig</a:t>
             </a:r>
-            <a:endParaRPr lang="en-US" sz="1400" dirty="0"/>
+            <a:endParaRPr lang="en-US" sz="1200" dirty="0"/>
           </a:p>
           <a:p>
             <a:pPr algn="l" indent="0" marL="0">
@@ -12811,7 +12868,7 @@
               <a:buNone/>
             </a:pPr>
             <a:r>
-              <a:rPr lang="en-US" sz="1400" i="1" dirty="0">
+              <a:rPr lang="en-US" sz="1200" i="1" dirty="0">
                 <a:solidFill>
                   <a:schemeClr val="tx1"/>
                 </a:solidFill>
@@ -12819,7 +12876,7 @@
               <a:t>-lijk</a:t>
             </a:r>
             <a:r>
-              <a:rPr lang="en-US" sz="1400" dirty="0">
+              <a:rPr lang="en-US" sz="1200" dirty="0">
                 <a:solidFill>
                   <a:schemeClr val="tx1"/>
                 </a:solidFill>
@@ -12827,14 +12884,14 @@
               <a:t> « leuk » : </a:t>
             </a:r>
             <a:r>
-              <a:rPr lang="en-US" sz="1400" i="1" dirty="0">
+              <a:rPr lang="en-US" sz="1200" i="1" dirty="0">
                 <a:solidFill>
                   <a:schemeClr val="tx1"/>
                 </a:solidFill>
               </a:rPr>
               <a:t>vrien·de·lijk</a:t>
             </a:r>
-            <a:endParaRPr lang="en-US" sz="1400" dirty="0"/>
+            <a:endParaRPr lang="en-US" sz="1200" dirty="0"/>
           </a:p>
         </p:txBody>
       </p:sp>
@@ -12898,7 +12955,7 @@
                   <a:schemeClr val="tx1"/>
                 </a:solidFill>
               </a:rPr>
-              <a:t>Un mot d’une syllabe</a:t>
+              <a:t>Un mot d’une syllabe lu seul</a:t>
             </a:r>
             <a:r>
               <a:rPr lang="en-US" sz="1400" dirty="0">
@@ -12906,7 +12963,47 @@
                   <a:schemeClr val="tx1"/>
                 </a:solidFill>
               </a:rPr>
-              <a:t> est toujours accentué :</a:t>
+              <a:t> est accentué : je lis la voyelle → </a:t>
+            </a:r>
+            <a:r>
+              <a:rPr lang="en-US" sz="1400" b="1" i="1" dirty="0">
+                <a:solidFill>
+                  <a:schemeClr val="accent4"/>
+                </a:solidFill>
+              </a:rPr>
+              <a:t>kat</a:t>
+            </a:r>
+            <a:r>
+              <a:rPr lang="en-US" sz="1400" dirty="0">
+                <a:solidFill>
+                  <a:schemeClr val="tx1"/>
+                </a:solidFill>
+              </a:rPr>
+              <a:t> · </a:t>
+            </a:r>
+            <a:r>
+              <a:rPr lang="en-US" sz="1400" b="1" i="1" dirty="0">
+                <a:solidFill>
+                  <a:schemeClr val="accent3"/>
+                </a:solidFill>
+              </a:rPr>
+              <a:t>maan</a:t>
+            </a:r>
+            <a:r>
+              <a:rPr lang="en-US" sz="1400" dirty="0">
+                <a:solidFill>
+                  <a:schemeClr val="tx1"/>
+                </a:solidFill>
+              </a:rPr>
+              <a:t> · </a:t>
+            </a:r>
+            <a:r>
+              <a:rPr lang="en-US" sz="1400" i="1" dirty="0">
+                <a:solidFill>
+                  <a:schemeClr val="tx1"/>
+                </a:solidFill>
+              </a:rPr>
+              <a:t>huis</a:t>
             </a:r>
             <a:endParaRPr lang="en-US" sz="1400" dirty="0"/>
           </a:p>
@@ -12923,15 +13020,15 @@
                   <a:schemeClr val="tx1"/>
                 </a:solidFill>
               </a:rPr>
-              <a:t>je lis la voyelle → </a:t>
-            </a:r>
-            <a:r>
-              <a:rPr lang="en-US" sz="1400" b="1" i="1" dirty="0">
-                <a:solidFill>
-                  <a:schemeClr val="accent4"/>
-                </a:solidFill>
-              </a:rPr>
-              <a:t>kat</a:t>
+              <a:t>Mais </a:t>
+            </a:r>
+            <a:r>
+              <a:rPr lang="en-US" sz="1400" i="1" dirty="0">
+                <a:solidFill>
+                  <a:schemeClr val="tx1"/>
+                </a:solidFill>
+              </a:rPr>
+              <a:t>de, je, het, een</a:t>
             </a:r>
             <a:r>
               <a:rPr lang="en-US" sz="1400" dirty="0">
@@ -12939,39 +13036,7 @@
                   <a:schemeClr val="tx1"/>
                 </a:solidFill>
               </a:rPr>
-              <a:t> (court) · </a:t>
-            </a:r>
-            <a:r>
-              <a:rPr lang="en-US" sz="1400" b="1" i="1" dirty="0">
-                <a:solidFill>
-                  <a:schemeClr val="accent3"/>
-                </a:solidFill>
-              </a:rPr>
-              <a:t>maan</a:t>
-            </a:r>
-            <a:r>
-              <a:rPr lang="en-US" sz="1400" dirty="0">
-                <a:solidFill>
-                  <a:schemeClr val="tx1"/>
-                </a:solidFill>
-              </a:rPr>
-              <a:t> (long) · </a:t>
-            </a:r>
-            <a:r>
-              <a:rPr lang="en-US" sz="1400" i="1" dirty="0">
-                <a:solidFill>
-                  <a:schemeClr val="tx1"/>
-                </a:solidFill>
-              </a:rPr>
-              <a:t>huis</a:t>
-            </a:r>
-            <a:r>
-              <a:rPr lang="en-US" sz="1400" dirty="0">
-                <a:solidFill>
-                  <a:schemeClr val="tx1"/>
-                </a:solidFill>
-              </a:rPr>
-              <a:t> (son double)</a:t>
+              <a:t> restent muets dans la phrase.</a:t>
             </a:r>
             <a:endParaRPr lang="en-US" sz="1400" dirty="0"/>
           </a:p>
@@ -26589,7 +26654,7 @@
                   <a:schemeClr val="tx1"/>
                 </a:solidFill>
               </a:rPr>
-              <a:t> lu « ou » → </a:t>
+              <a:t> lu comme dans « lui » → </a:t>
             </a:r>
             <a:r>
               <a:rPr lang="en-US" sz="1600" i="1" dirty="0">
@@ -26622,7 +26687,7 @@
                   <a:schemeClr val="tx1"/>
                 </a:solidFill>
               </a:rPr>
-              <a:t>eu</a:t>
+              <a:t>u</a:t>
             </a:r>
             <a:r>
               <a:rPr lang="en-US" sz="1600" dirty="0">
@@ -26638,7 +26703,7 @@
                   <a:schemeClr val="tx1"/>
                 </a:solidFill>
               </a:rPr>
-              <a:t>deur</a:t>
+              <a:t>bus</a:t>
             </a:r>
             <a:r>
               <a:rPr lang="en-US" sz="1600" dirty="0">
@@ -26646,7 +26711,7 @@
                   <a:schemeClr val="tx1"/>
                 </a:solidFill>
               </a:rPr>
-              <a:t> ≈ « deur »</a:t>
+              <a:t> ≈ « beus »</a:t>
             </a:r>
             <a:endParaRPr lang="en-US" sz="1600" dirty="0"/>
           </a:p>
@@ -26663,6 +26728,47 @@
                   <a:schemeClr val="tx1"/>
                 </a:solidFill>
               </a:rPr>
+              <a:t>ij</a:t>
+            </a:r>
+            <a:r>
+              <a:rPr lang="en-US" sz="1600" dirty="0">
+                <a:solidFill>
+                  <a:schemeClr val="tx1"/>
+                </a:solidFill>
+              </a:rPr>
+              <a:t> lu « i » → </a:t>
+            </a:r>
+            <a:r>
+              <a:rPr lang="en-US" sz="1600" i="1" dirty="0">
+                <a:solidFill>
+                  <a:schemeClr val="tx1"/>
+                </a:solidFill>
+              </a:rPr>
+              <a:t>prijs</a:t>
+            </a:r>
+            <a:r>
+              <a:rPr lang="en-US" sz="1600" dirty="0">
+                <a:solidFill>
+                  <a:schemeClr val="tx1"/>
+                </a:solidFill>
+              </a:rPr>
+              <a:t> ≈ « prèïs »</a:t>
+            </a:r>
+            <a:endParaRPr lang="en-US" sz="1600" dirty="0"/>
+          </a:p>
+          <a:p>
+            <a:pPr algn="l" indent="0" marL="0">
+              <a:spcAft>
+                <a:spcPts val="600"/>
+              </a:spcAft>
+              <a:buNone/>
+            </a:pPr>
+            <a:r>
+              <a:rPr lang="en-US" sz="1600" i="1" dirty="0">
+                <a:solidFill>
+                  <a:schemeClr val="tx1"/>
+                </a:solidFill>
+              </a:rPr>
               <a:t>oe</a:t>
             </a:r>
             <a:r>
@@ -26671,7 +26777,7 @@
                   <a:schemeClr val="tx1"/>
                 </a:solidFill>
               </a:rPr>
-              <a:t> lu « u » → </a:t>
+              <a:t> lu « o-é » → </a:t>
             </a:r>
             <a:r>
               <a:rPr lang="en-US" sz="1600" i="1" dirty="0">
@@ -30769,7 +30875,7 @@
                   <a:schemeClr val="tx1"/>
                 </a:solidFill>
               </a:rPr>
-              <a:t> « s-ch »</a:t>
+              <a:t> « s » + ch raclé</a:t>
             </a:r>
             <a:endParaRPr lang="en-US" sz="1500" dirty="0"/>
           </a:p>
@@ -30964,7 +31070,7 @@
                   <a:schemeClr val="tx1"/>
                 </a:solidFill>
               </a:rPr>
-              <a:t> « ghout »</a:t>
+              <a:t> « ghout » (gh raclé)</a:t>
             </a:r>
             <a:endParaRPr lang="en-US" sz="1500" dirty="0"/>
           </a:p>
@@ -31080,7 +31186,7 @@
                   <a:schemeClr val="tx1"/>
                 </a:solidFill>
               </a:rPr>
-              <a:t> « o-ran-gneu »</a:t>
+              <a:t> « o-ra-gneu »</a:t>
             </a:r>
             <a:endParaRPr lang="en-US" sz="1500" dirty="0"/>
           </a:p>
@@ -31163,7 +31269,7 @@
                   <a:schemeClr val="tx1"/>
                 </a:solidFill>
               </a:rPr>
-              <a:t> « tchè-chi-yeu »</a:t>
+              <a:t> « tchè-ghi-yeu »</a:t>
             </a:r>
             <a:endParaRPr lang="en-US" sz="1500" dirty="0"/>
           </a:p>
@@ -32543,8 +32649,17 @@
                   <a:schemeClr val="tx1"/>
                 </a:solidFill>
               </a:rPr>
-              <a:t> 2 · </a:t>
-            </a:r>
+              <a:t> 2</a:t>
+            </a:r>
+            <a:endParaRPr lang="en-US" sz="1500" dirty="0"/>
+          </a:p>
+          <a:p>
+            <a:pPr algn="l" indent="0" marL="0">
+              <a:spcAft>
+                <a:spcPts val="500"/>
+              </a:spcAft>
+              <a:buNone/>
+            </a:pPr>
             <a:r>
               <a:rPr lang="en-US" sz="1500" b="1" i="1" dirty="0">
                 <a:solidFill>
@@ -32567,7 +32682,39 @@
                   <a:schemeClr val="tx1"/>
                 </a:solidFill>
               </a:rPr>
-              <a:t> 3</a:t>
+              <a:t> 3 (BE : </a:t>
+            </a:r>
+            <a:r>
+              <a:rPr lang="en-US" sz="1500" i="1" dirty="0">
+                <a:solidFill>
+                  <a:schemeClr val="tx1"/>
+                </a:solidFill>
+              </a:rPr>
+              <a:t>ge·</a:t>
+            </a:r>
+            <a:r>
+              <a:rPr lang="en-US" sz="1500" b="1" i="1" dirty="0">
+                <a:solidFill>
+                  <a:schemeClr val="accent1"/>
+                </a:solidFill>
+              </a:rPr>
+              <a:t>mak</a:t>
+            </a:r>
+            <a:r>
+              <a:rPr lang="en-US" sz="1500" i="1" dirty="0">
+                <a:solidFill>
+                  <a:schemeClr val="tx1"/>
+                </a:solidFill>
+              </a:rPr>
+              <a:t>·ke·lijk</a:t>
+            </a:r>
+            <a:r>
+              <a:rPr lang="en-US" sz="1500" dirty="0">
+                <a:solidFill>
+                  <a:schemeClr val="tx1"/>
+                </a:solidFill>
+              </a:rPr>
+              <a:t> 4)</a:t>
             </a:r>
             <a:endParaRPr lang="en-US" sz="1500" dirty="0"/>
           </a:p>
@@ -33864,7 +34011,7 @@
                   <a:schemeClr val="tx1"/>
                 </a:solidFill>
               </a:rPr>
-              <a:t>4 Huit oies grises allaient hier, contentes, à Gand.</a:t>
+              <a:t>4 Huit oies grises sont allées hier, toutes contentes, à Gand.</a:t>
             </a:r>
             <a:endParaRPr lang="en-US" sz="1400" dirty="0"/>
           </a:p>
@@ -34185,7 +34332,7 @@
                   <a:schemeClr val="tx1"/>
                 </a:solidFill>
               </a:rPr>
-              <a:t>⑥ « mèï-cheu » · « o-ran-gneu » · « tchè-chi-yeu »</a:t>
+              <a:t>⑥ « mèï-cheu » · « o-ra-gneu » · « tchè-ghi-yeu »</a:t>
             </a:r>
             <a:endParaRPr lang="en-US" sz="1400" dirty="0"/>
           </a:p>
@@ -37557,23 +37704,7 @@
                   <a:schemeClr val="bg1"/>
                 </a:solidFill>
               </a:rPr>
-              <a:t> « mur », long — le </a:t>
-            </a:r>
-            <a:r>
-              <a:rPr lang="en-US" sz="1700" i="1" dirty="0">
-                <a:solidFill>
-                  <a:schemeClr val="bg1"/>
-                </a:solidFill>
-              </a:rPr>
-              <a:t>i</a:t>
-            </a:r>
-            <a:r>
-              <a:rPr lang="en-US" sz="1700" dirty="0">
-                <a:solidFill>
-                  <a:schemeClr val="bg1"/>
-                </a:solidFill>
-              </a:rPr>
-              <a:t> long s’écrit toujours </a:t>
+              <a:t> « mur », long — le son « i » s’écrit presque toujours </a:t>
             </a:r>
             <a:r>
               <a:rPr lang="en-US" sz="1700" i="1" dirty="0">
@@ -48424,7 +48555,7 @@
                   <a:schemeClr val="tx1"/>
                 </a:solidFill>
               </a:rPr>
-              <a:t>Moeders snijden reuze uien.</a:t>
+              <a:t>Moeders snijden reuzenuien.</a:t>
             </a:r>
             <a:endParaRPr lang="en-US" sz="1900" dirty="0"/>
           </a:p>
@@ -48874,7 +49005,7 @@
                   <a:schemeClr val="tx1"/>
                 </a:solidFill>
               </a:rPr>
-              <a:t>IJskoud bier uit de keuken van moe.</a:t>
+              <a:t>IJskoud bier uit de keuken van Koen.</a:t>
             </a:r>
             <a:endParaRPr lang="en-US" sz="1900" dirty="0"/>
           </a:p>
@@ -51973,8 +52104,8 @@
         </p:nvSpPr>
         <p:spPr>
           <a:xfrm>
-            <a:off x="6501384" y="3971544"/>
-            <a:ext cx="4956048" cy="1417320"/>
+            <a:off x="6501384" y="3925824"/>
+            <a:ext cx="4956048" cy="1508760"/>
           </a:xfrm>
           <a:prstGeom prst="rect">
             <a:avLst/>
@@ -51988,12 +52119,12 @@
           <a:p>
             <a:pPr algn="l" indent="0" marL="0">
               <a:spcAft>
-                <a:spcPts val="600"/>
+                <a:spcPts val="400"/>
               </a:spcAft>
               <a:buNone/>
             </a:pPr>
             <a:r>
-              <a:rPr lang="en-US" sz="1600" b="1" i="1" dirty="0">
+              <a:rPr lang="en-US" sz="1500" b="1" i="1" dirty="0">
                 <a:solidFill>
                   <a:schemeClr val="tx1"/>
                 </a:solidFill>
@@ -52001,7 +52132,7 @@
               <a:t>sch</a:t>
             </a:r>
             <a:r>
-              <a:rPr lang="en-US" sz="1600" i="1" dirty="0">
+              <a:rPr lang="en-US" sz="1500" i="1" dirty="0">
                 <a:solidFill>
                   <a:schemeClr val="tx1"/>
                 </a:solidFill>
@@ -52009,7 +52140,7 @@
               <a:t>ool</a:t>
             </a:r>
             <a:r>
-              <a:rPr lang="en-US" sz="1600" dirty="0">
+              <a:rPr lang="en-US" sz="1500" dirty="0">
                 <a:solidFill>
                   <a:schemeClr val="tx1"/>
                 </a:solidFill>
@@ -52017,7 +52148,7 @@
               <a:t> = « s » + </a:t>
             </a:r>
             <a:r>
-              <a:rPr lang="en-US" sz="1600" i="1" dirty="0">
+              <a:rPr lang="en-US" sz="1500" i="1" dirty="0">
                 <a:solidFill>
                   <a:schemeClr val="tx1"/>
                 </a:solidFill>
@@ -52025,24 +52156,24 @@
               <a:t>ch</a:t>
             </a:r>
             <a:r>
-              <a:rPr lang="en-US" sz="1600" dirty="0">
+              <a:rPr lang="en-US" sz="1500" dirty="0">
                 <a:solidFill>
                   <a:schemeClr val="tx1"/>
                 </a:solidFill>
               </a:rPr>
               <a:t> raclé</a:t>
             </a:r>
-            <a:endParaRPr lang="en-US" sz="1600" dirty="0"/>
+            <a:endParaRPr lang="en-US" sz="1500" dirty="0"/>
           </a:p>
           <a:p>
             <a:pPr algn="l" indent="0" marL="0">
               <a:spcAft>
-                <a:spcPts val="600"/>
+                <a:spcPts val="400"/>
               </a:spcAft>
               <a:buNone/>
             </a:pPr>
             <a:r>
-              <a:rPr lang="en-US" sz="1600" i="1" dirty="0">
+              <a:rPr lang="en-US" sz="1500" i="1" dirty="0">
                 <a:solidFill>
                   <a:schemeClr val="tx1"/>
                 </a:solidFill>
@@ -52050,7 +52181,7 @@
               <a:t>Russi</a:t>
             </a:r>
             <a:r>
-              <a:rPr lang="en-US" sz="1600" b="1" i="1" dirty="0">
+              <a:rPr lang="en-US" sz="1500" b="1" i="1" dirty="0">
                 <a:solidFill>
                   <a:schemeClr val="tx1"/>
                 </a:solidFill>
@@ -52058,7 +52189,7 @@
               <a:t>sch</a:t>
             </a:r>
             <a:r>
-              <a:rPr lang="en-US" sz="1600" dirty="0">
+              <a:rPr lang="en-US" sz="1500" dirty="0">
                 <a:solidFill>
                   <a:schemeClr val="tx1"/>
                 </a:solidFill>
@@ -52066,7 +52197,7 @@
               <a:t> = « is » (</a:t>
             </a:r>
             <a:r>
-              <a:rPr lang="en-US" sz="1600" i="1" dirty="0">
+              <a:rPr lang="en-US" sz="1500" i="1" dirty="0">
                 <a:solidFill>
                   <a:schemeClr val="tx1"/>
                 </a:solidFill>
@@ -52074,24 +52205,57 @@
               <a:t>-isch</a:t>
             </a:r>
             <a:r>
-              <a:rPr lang="en-US" sz="1600" dirty="0">
+              <a:rPr lang="en-US" sz="1500" dirty="0">
                 <a:solidFill>
                   <a:schemeClr val="tx1"/>
                 </a:solidFill>
               </a:rPr>
               <a:t> en fin de mot)</a:t>
             </a:r>
-            <a:endParaRPr lang="en-US" sz="1600" dirty="0"/>
+            <a:endParaRPr lang="en-US" sz="1500" dirty="0"/>
           </a:p>
           <a:p>
             <a:pPr algn="l" indent="0" marL="0">
               <a:spcAft>
-                <a:spcPts val="600"/>
+                <a:spcPts val="400"/>
               </a:spcAft>
               <a:buNone/>
             </a:pPr>
             <a:r>
-              <a:rPr lang="en-US" sz="1600" dirty="0">
+              <a:rPr lang="en-US" sz="1500" dirty="0">
+                <a:solidFill>
+                  <a:schemeClr val="tx1"/>
+                </a:solidFill>
+              </a:rPr>
+              <a:t>Repère : « gh » = raclé (</a:t>
+            </a:r>
+            <a:r>
+              <a:rPr lang="en-US" sz="1500" i="1" dirty="0">
+                <a:solidFill>
+                  <a:schemeClr val="tx1"/>
+                </a:solidFill>
+              </a:rPr>
+              <a:t>goed</a:t>
+            </a:r>
+            <a:r>
+              <a:rPr lang="en-US" sz="1500" dirty="0">
+                <a:solidFill>
+                  <a:schemeClr val="tx1"/>
+                </a:solidFill>
+              </a:rPr>
+              <a:t> ≈ « ghout »)</a:t>
+            </a:r>
+            <a:endParaRPr lang="en-US" sz="1500" dirty="0"/>
+          </a:p>
+          <a:p>
+            <a:pPr algn="l" indent="0" marL="0">
+              <a:spcAft>
+                <a:spcPts val="400"/>
+              </a:spcAft>
+              <a:buNone/>
+            </a:pPr>
+            <a:r>
+              <a:rPr lang="en-US" sz="1500" dirty="0">
                 <a:solidFill>
                   <a:schemeClr val="tx1"/>
                 </a:solidFill>
@@ -52099,7 +52263,7 @@
               <a:t>En Belgique, le </a:t>
             </a:r>
             <a:r>
-              <a:rPr lang="en-US" sz="1600" i="1" dirty="0">
+              <a:rPr lang="en-US" sz="1500" i="1" dirty="0">
                 <a:solidFill>
                   <a:schemeClr val="tx1"/>
                 </a:solidFill>
@@ -52107,14 +52271,14 @@
               <a:t>g</a:t>
             </a:r>
             <a:r>
-              <a:rPr lang="en-US" sz="1600" dirty="0">
+              <a:rPr lang="en-US" sz="1500" dirty="0">
                 <a:solidFill>
                   <a:schemeClr val="tx1"/>
                 </a:solidFill>
               </a:rPr>
               <a:t> est plus doux : c’est correct !</a:t>
             </a:r>
-            <a:endParaRPr lang="en-US" sz="1600" dirty="0"/>
+            <a:endParaRPr lang="en-US" sz="1500" dirty="0"/>
           </a:p>
         </p:txBody>
       </p:sp>

</xml_diff>